<commit_message>
docs: update slide 7 to single integrated service model (platform + consulting)
Replaces the two-option service model (self-service vs consultancy) with a
unified model where the instrument always includes consulting accompaniment
in results analysis, matching the product positioning.

Co-Authored-By: Claude Opus 4.6 <noreply@anthropic.com>
</commit_message>
<xml_diff>
--- a/docs/climalab-whitelabel-deck.pptx
+++ b/docs/climalab-whitelabel-deck.pptx
@@ -5033,7 +5033,7 @@
                 <a:ea typeface="Trebuchet MS" pitchFamily="34" charset="-122"/>
                 <a:cs typeface="Trebuchet MS" pitchFamily="34" charset="-120"/>
               </a:rPr>
-              <a:t>Dos formas de trabajar según el nivel de acompañamiento que necesitas</a:t>
+              <a:t>Un diagnóstico completo con acompañamiento experto</a:t>
             </a:r>
             <a:endParaRPr lang="en-US" sz="2800" dirty="0"/>
           </a:p>
@@ -5041,14 +5041,56 @@
       </p:sp>
       <p:sp>
         <p:nvSpPr>
-          <p:cNvPr id="3" name="Shape 1"/>
-          <p:cNvSpPr/>
-          <p:nvPr/>
-        </p:nvSpPr>
-        <p:spPr>
-          <a:xfrm>
-            <a:off x="731520" y="1463040"/>
-            <a:ext cx="5029200" cy="4206240"/>
+          <p:cNvPr id="3" name="Text 1"/>
+          <p:cNvSpPr/>
+          <p:nvPr/>
+        </p:nvSpPr>
+        <p:spPr>
+          <a:xfrm>
+            <a:off x="731520" y="1188720"/>
+            <a:ext cx="10515600" cy="640080"/>
+          </a:xfrm>
+          <a:prstGeom prst="rect">
+            <a:avLst/>
+          </a:prstGeom>
+          <a:noFill/>
+          <a:ln/>
+        </p:spPr>
+        <p:txBody>
+          <a:bodyPr wrap="square" rtlCol="0" anchor="ctr"/>
+          <a:lstStyle/>
+          <a:p>
+            <a:pPr indent="0" marL="0">
+              <a:lnSpc>
+                <a:spcPct val="130000"/>
+              </a:lnSpc>
+              <a:buNone/>
+            </a:pPr>
+            <a:r>
+              <a:rPr lang="en-US" sz="1400" dirty="0">
+                <a:solidFill>
+                  <a:srgbClr val="4A5568"/>
+                </a:solidFill>
+                <a:latin typeface="Calibri" pitchFamily="34" charset="0"/>
+                <a:ea typeface="Calibri" pitchFamily="34" charset="-122"/>
+                <a:cs typeface="Calibri" pitchFamily="34" charset="-120"/>
+              </a:rPr>
+              <a:t>No entregamos una plataforma para que te las arregles solo. El instrumento siempre se acompaña de interpretación estratégica para que los datos se conviertan en decisiones.</a:t>
+            </a:r>
+            <a:endParaRPr lang="en-US" sz="1400" dirty="0"/>
+          </a:p>
+        </p:txBody>
+      </p:sp>
+      <p:sp>
+        <p:nvSpPr>
+          <p:cNvPr id="4" name="Shape 2"/>
+          <p:cNvSpPr/>
+          <p:nvPr/>
+        </p:nvSpPr>
+        <p:spPr>
+          <a:xfrm>
+            <a:off x="731520" y="2194560"/>
+            <a:ext cx="5029200" cy="4023360"/>
           </a:xfrm>
           <a:prstGeom prst="rect">
             <a:avLst/>
@@ -5068,13 +5110,13 @@
       </p:sp>
       <p:sp>
         <p:nvSpPr>
-          <p:cNvPr id="4" name="Shape 2"/>
-          <p:cNvSpPr/>
-          <p:nvPr/>
-        </p:nvSpPr>
-        <p:spPr>
-          <a:xfrm>
-            <a:off x="731520" y="1463040"/>
+          <p:cNvPr id="5" name="Shape 3"/>
+          <p:cNvSpPr/>
+          <p:nvPr/>
+        </p:nvSpPr>
+        <p:spPr>
+          <a:xfrm>
+            <a:off x="731520" y="2194560"/>
             <a:ext cx="5029200" cy="54864"/>
           </a:xfrm>
           <a:prstGeom prst="rect">
@@ -5088,162 +5130,115 @@
       </p:sp>
       <p:sp>
         <p:nvSpPr>
-          <p:cNvPr id="5" name="Text 3"/>
-          <p:cNvSpPr/>
-          <p:nvPr/>
-        </p:nvSpPr>
-        <p:spPr>
-          <a:xfrm>
-            <a:off x="1005840" y="1737360"/>
-            <a:ext cx="1645920" cy="320040"/>
-          </a:xfrm>
-          <a:prstGeom prst="roundRect">
-            <a:avLst>
-              <a:gd name="adj" fmla="val 14286"/>
-            </a:avLst>
-          </a:prstGeom>
-          <a:solidFill>
-            <a:srgbClr val="F0FAFA"/>
-          </a:solidFill>
-          <a:ln w="12700">
-            <a:solidFill>
-              <a:srgbClr val="028090"/>
-            </a:solidFill>
-          </a:ln>
-        </p:spPr>
-        <p:txBody>
-          <a:bodyPr wrap="square" rtlCol="0" anchor="ctr"/>
-          <a:lstStyle/>
-          <a:p>
-            <a:pPr algn="ctr" indent="0" marL="0">
-              <a:buNone/>
-            </a:pPr>
-            <a:r>
-              <a:rPr lang="en-US" sz="1000" b="1" dirty="0">
+          <p:cNvPr id="6" name="Text 4"/>
+          <p:cNvSpPr/>
+          <p:nvPr/>
+        </p:nvSpPr>
+        <p:spPr>
+          <a:xfrm>
+            <a:off x="1005840" y="2423160"/>
+            <a:ext cx="4480560" cy="411480"/>
+          </a:xfrm>
+          <a:prstGeom prst="rect">
+            <a:avLst/>
+          </a:prstGeom>
+          <a:noFill/>
+          <a:ln/>
+        </p:spPr>
+        <p:txBody>
+          <a:bodyPr wrap="square" rtlCol="0" anchor="ctr"/>
+          <a:lstStyle/>
+          <a:p>
+            <a:pPr indent="0" marL="0">
+              <a:buNone/>
+            </a:pPr>
+            <a:r>
+              <a:rPr lang="en-US" sz="1800" b="1" dirty="0">
                 <a:solidFill>
                   <a:srgbClr val="028090"/>
+                </a:solidFill>
+                <a:latin typeface="Trebuchet MS" pitchFamily="34" charset="0"/>
+                <a:ea typeface="Trebuchet MS" pitchFamily="34" charset="-122"/>
+                <a:cs typeface="Trebuchet MS" pitchFamily="34" charset="-120"/>
+              </a:rPr>
+              <a:t>📊  Plataforma</a:t>
+            </a:r>
+            <a:endParaRPr lang="en-US" sz="1800" dirty="0"/>
+          </a:p>
+        </p:txBody>
+      </p:sp>
+      <p:sp>
+        <p:nvSpPr>
+          <p:cNvPr id="7" name="Text 5"/>
+          <p:cNvSpPr/>
+          <p:nvPr/>
+        </p:nvSpPr>
+        <p:spPr>
+          <a:xfrm>
+            <a:off x="1005840" y="2971800"/>
+            <a:ext cx="4480560" cy="3017520"/>
+          </a:xfrm>
+          <a:prstGeom prst="rect">
+            <a:avLst/>
+          </a:prstGeom>
+          <a:noFill/>
+          <a:ln/>
+        </p:spPr>
+        <p:txBody>
+          <a:bodyPr wrap="square" rtlCol="0" anchor="ctr"/>
+          <a:lstStyle/>
+          <a:p>
+            <a:pPr marL="342900" indent="-342900">
+              <a:lnSpc>
+                <a:spcPct val="145000"/>
+              </a:lnSpc>
+              <a:buSzPct val="100000"/>
+              <a:buChar char="✓"/>
+            </a:pPr>
+            <a:r>
+              <a:rPr lang="en-US" sz="1150" dirty="0">
+                <a:solidFill>
+                  <a:srgbClr val="1A1A2E"/>
                 </a:solidFill>
                 <a:latin typeface="Calibri" pitchFamily="34" charset="0"/>
                 <a:ea typeface="Calibri" pitchFamily="34" charset="-122"/>
                 <a:cs typeface="Calibri" pitchFamily="34" charset="-120"/>
               </a:rPr>
-              <a:t>PLATAFORMA</a:t>
-            </a:r>
-            <a:endParaRPr lang="en-US" sz="1000" dirty="0"/>
-          </a:p>
-        </p:txBody>
-      </p:sp>
-      <p:sp>
-        <p:nvSpPr>
-          <p:cNvPr id="6" name="Text 4"/>
-          <p:cNvSpPr/>
-          <p:nvPr/>
-        </p:nvSpPr>
-        <p:spPr>
-          <a:xfrm>
-            <a:off x="1005840" y="2240280"/>
-            <a:ext cx="4480560" cy="365760"/>
-          </a:xfrm>
-          <a:prstGeom prst="rect">
-            <a:avLst/>
-          </a:prstGeom>
-          <a:noFill/>
-          <a:ln/>
-        </p:spPr>
-        <p:txBody>
-          <a:bodyPr wrap="square" rtlCol="0" anchor="ctr"/>
-          <a:lstStyle/>
-          <a:p>
-            <a:pPr indent="0" marL="0">
-              <a:buNone/>
-            </a:pPr>
-            <a:r>
-              <a:rPr lang="en-US" sz="1600" b="1" dirty="0">
+              <a:t>Instrumento Core (107 ítems, 22 dimensiones) o Pulso (22 ítems ancla)</a:t>
+            </a:r>
+            <a:endParaRPr lang="en-US" sz="1150" dirty="0"/>
+          </a:p>
+          <a:p>
+            <a:pPr marL="342900" indent="-342900">
+              <a:lnSpc>
+                <a:spcPct val="145000"/>
+              </a:lnSpc>
+              <a:buSzPct val="100000"/>
+              <a:buChar char="✓"/>
+            </a:pPr>
+            <a:r>
+              <a:rPr lang="en-US" sz="1150" dirty="0">
                 <a:solidFill>
                   <a:srgbClr val="1A1A2E"/>
-                </a:solidFill>
-                <a:latin typeface="Trebuchet MS" pitchFamily="34" charset="0"/>
-                <a:ea typeface="Trebuchet MS" pitchFamily="34" charset="-122"/>
-                <a:cs typeface="Trebuchet MS" pitchFamily="34" charset="-120"/>
-              </a:rPr>
-              <a:t>Diagnóstico autogestionado</a:t>
-            </a:r>
-            <a:endParaRPr lang="en-US" sz="1600" dirty="0"/>
-          </a:p>
-        </p:txBody>
-      </p:sp>
-      <p:sp>
-        <p:nvSpPr>
-          <p:cNvPr id="7" name="Text 5"/>
-          <p:cNvSpPr/>
-          <p:nvPr/>
-        </p:nvSpPr>
-        <p:spPr>
-          <a:xfrm>
-            <a:off x="1005840" y="2651760"/>
-            <a:ext cx="4480560" cy="731520"/>
-          </a:xfrm>
-          <a:prstGeom prst="rect">
-            <a:avLst/>
-          </a:prstGeom>
-          <a:noFill/>
-          <a:ln/>
-        </p:spPr>
-        <p:txBody>
-          <a:bodyPr wrap="square" rtlCol="0" anchor="ctr"/>
-          <a:lstStyle/>
-          <a:p>
-            <a:pPr indent="0" marL="0">
-              <a:lnSpc>
-                <a:spcPct val="130000"/>
-              </a:lnSpc>
-              <a:buNone/>
-            </a:pPr>
-            <a:r>
-              <a:rPr lang="en-US" sz="1200" dirty="0">
-                <a:solidFill>
-                  <a:srgbClr val="4A5568"/>
                 </a:solidFill>
                 <a:latin typeface="Calibri" pitchFamily="34" charset="0"/>
                 <a:ea typeface="Calibri" pitchFamily="34" charset="-122"/>
                 <a:cs typeface="Calibri" pitchFamily="34" charset="-120"/>
               </a:rPr>
-              <a:t>Acceso completo a la plataforma. Tu equipo configura, lanza y analiza. Ideal para organizaciones con capacidad interna de RRHH o People Analytics.</a:t>
-            </a:r>
-            <a:endParaRPr lang="en-US" sz="1200" dirty="0"/>
-          </a:p>
-        </p:txBody>
-      </p:sp>
-      <p:sp>
-        <p:nvSpPr>
-          <p:cNvPr id="8" name="Text 6"/>
-          <p:cNvSpPr/>
-          <p:nvPr/>
-        </p:nvSpPr>
-        <p:spPr>
-          <a:xfrm>
-            <a:off x="1005840" y="3566160"/>
-            <a:ext cx="4480560" cy="1828800"/>
-          </a:xfrm>
-          <a:prstGeom prst="rect">
-            <a:avLst/>
-          </a:prstGeom>
-          <a:noFill/>
-          <a:ln/>
-        </p:spPr>
-        <p:txBody>
-          <a:bodyPr wrap="square" rtlCol="0" anchor="ctr"/>
-          <a:lstStyle/>
+              <a:t>Módulos opcionales: Cambio, Cliente, Digital</a:t>
+            </a:r>
+            <a:endParaRPr lang="en-US" sz="1150" dirty="0"/>
+          </a:p>
           <a:p>
             <a:pPr marL="342900" indent="-342900">
               <a:lnSpc>
-                <a:spcPct val="150000"/>
+                <a:spcPct val="145000"/>
               </a:lnSpc>
               <a:buSzPct val="100000"/>
               <a:buChar char="✓"/>
             </a:pPr>
             <a:r>
-              <a:rPr lang="en-US" sz="1200" dirty="0">
+              <a:rPr lang="en-US" sz="1150" dirty="0">
                 <a:solidFill>
                   <a:srgbClr val="1A1A2E"/>
                 </a:solidFill>
@@ -5251,20 +5246,20 @@
                 <a:ea typeface="Calibri" pitchFamily="34" charset="-122"/>
                 <a:cs typeface="Calibri" pitchFamily="34" charset="-120"/>
               </a:rPr>
-              <a:t>Instrumento Core (107 ítems) o Pulso (22 ítems)</a:t>
-            </a:r>
-            <a:endParaRPr lang="en-US" sz="1200" dirty="0"/>
+              <a:t>Encuesta anónima con marca de tu organización</a:t>
+            </a:r>
+            <a:endParaRPr lang="en-US" sz="1150" dirty="0"/>
           </a:p>
           <a:p>
             <a:pPr marL="342900" indent="-342900">
               <a:lnSpc>
-                <a:spcPct val="150000"/>
+                <a:spcPct val="145000"/>
               </a:lnSpc>
               <a:buSzPct val="100000"/>
               <a:buChar char="✓"/>
             </a:pPr>
             <a:r>
-              <a:rPr lang="en-US" sz="1200" dirty="0">
+              <a:rPr lang="en-US" sz="1150" dirty="0">
                 <a:solidFill>
                   <a:srgbClr val="1A1A2E"/>
                 </a:solidFill>
@@ -5272,20 +5267,20 @@
                 <a:ea typeface="Calibri" pitchFamily="34" charset="-122"/>
                 <a:cs typeface="Calibri" pitchFamily="34" charset="-120"/>
               </a:rPr>
-              <a:t>Dashboard completo con 11 vistas</a:t>
-            </a:r>
-            <a:endParaRPr lang="en-US" sz="1200" dirty="0"/>
+              <a:t>Dashboard interactivo con 11 vistas de resultados</a:t>
+            </a:r>
+            <a:endParaRPr lang="en-US" sz="1150" dirty="0"/>
           </a:p>
           <a:p>
             <a:pPr marL="342900" indent="-342900">
               <a:lnSpc>
-                <a:spcPct val="150000"/>
+                <a:spcPct val="145000"/>
               </a:lnSpc>
               <a:buSzPct val="100000"/>
               <a:buChar char="✓"/>
             </a:pPr>
             <a:r>
-              <a:rPr lang="en-US" sz="1200" dirty="0">
+              <a:rPr lang="en-US" sz="1150" dirty="0">
                 <a:solidFill>
                   <a:srgbClr val="1A1A2E"/>
                 </a:solidFill>
@@ -5293,20 +5288,20 @@
                 <a:ea typeface="Calibri" pitchFamily="34" charset="-122"/>
                 <a:cs typeface="Calibri" pitchFamily="34" charset="-120"/>
               </a:rPr>
-              <a:t>Exportación DOCX y Excel</a:t>
-            </a:r>
-            <a:endParaRPr lang="en-US" sz="1200" dirty="0"/>
+              <a:t>Motor estadístico: rwg, Cronbach, Pearson, eNPS</a:t>
+            </a:r>
+            <a:endParaRPr lang="en-US" sz="1150" dirty="0"/>
           </a:p>
           <a:p>
             <a:pPr marL="342900" indent="-342900">
               <a:lnSpc>
-                <a:spcPct val="150000"/>
+                <a:spcPct val="145000"/>
               </a:lnSpc>
               <a:buSzPct val="100000"/>
               <a:buChar char="✓"/>
             </a:pPr>
             <a:r>
-              <a:rPr lang="en-US" sz="1200" dirty="0">
+              <a:rPr lang="en-US" sz="1150" dirty="0">
                 <a:solidFill>
                   <a:srgbClr val="1A1A2E"/>
                 </a:solidFill>
@@ -5314,28 +5309,70 @@
                 <a:ea typeface="Calibri" pitchFamily="34" charset="-122"/>
                 <a:cs typeface="Calibri" pitchFamily="34" charset="-120"/>
               </a:rPr>
-              <a:t>Insights de IA automáticos</a:t>
-            </a:r>
-            <a:endParaRPr lang="en-US" sz="1200" dirty="0"/>
-          </a:p>
-        </p:txBody>
-      </p:sp>
-      <p:sp>
-        <p:nvSpPr>
-          <p:cNvPr id="9" name="Shape 7"/>
-          <p:cNvSpPr/>
-          <p:nvPr/>
-        </p:nvSpPr>
-        <p:spPr>
-          <a:xfrm>
-            <a:off x="6400800" y="1463040"/>
-            <a:ext cx="5029200" cy="4206240"/>
+              <a:t>Análisis de redes organizacionales (ONA)</a:t>
+            </a:r>
+            <a:endParaRPr lang="en-US" sz="1150" dirty="0"/>
+          </a:p>
+          <a:p>
+            <a:pPr marL="342900" indent="-342900">
+              <a:lnSpc>
+                <a:spcPct val="145000"/>
+              </a:lnSpc>
+              <a:buSzPct val="100000"/>
+              <a:buChar char="✓"/>
+            </a:pPr>
+            <a:r>
+              <a:rPr lang="en-US" sz="1150" dirty="0">
+                <a:solidFill>
+                  <a:srgbClr val="1A1A2E"/>
+                </a:solidFill>
+                <a:latin typeface="Calibri" pitchFamily="34" charset="0"/>
+                <a:ea typeface="Calibri" pitchFamily="34" charset="-122"/>
+                <a:cs typeface="Calibri" pitchFamily="34" charset="-120"/>
+              </a:rPr>
+              <a:t>Insights generados por IA (6 tipos de análisis)</a:t>
+            </a:r>
+            <a:endParaRPr lang="en-US" sz="1150" dirty="0"/>
+          </a:p>
+          <a:p>
+            <a:pPr marL="342900" indent="-342900">
+              <a:lnSpc>
+                <a:spcPct val="145000"/>
+              </a:lnSpc>
+              <a:buSzPct val="100000"/>
+              <a:buChar char="✓"/>
+            </a:pPr>
+            <a:r>
+              <a:rPr lang="en-US" sz="1150" dirty="0">
+                <a:solidFill>
+                  <a:srgbClr val="1A1A2E"/>
+                </a:solidFill>
+                <a:latin typeface="Calibri" pitchFamily="34" charset="0"/>
+                <a:ea typeface="Calibri" pitchFamily="34" charset="-122"/>
+                <a:cs typeface="Calibri" pitchFamily="34" charset="-120"/>
+              </a:rPr>
+              <a:t>Exportación: DOCX ejecutivo, Excel completo, CSV</a:t>
+            </a:r>
+            <a:endParaRPr lang="en-US" sz="1150" dirty="0"/>
+          </a:p>
+        </p:txBody>
+      </p:sp>
+      <p:sp>
+        <p:nvSpPr>
+          <p:cNvPr id="8" name="Shape 6"/>
+          <p:cNvSpPr/>
+          <p:nvPr/>
+        </p:nvSpPr>
+        <p:spPr>
+          <a:xfrm>
+            <a:off x="6400800" y="2194560"/>
+            <a:ext cx="5029200" cy="4023360"/>
           </a:xfrm>
           <a:prstGeom prst="rect">
             <a:avLst/>
           </a:prstGeom>
           <a:solidFill>
-            <a:srgbClr val="FFFFFF"/>
+            <a:srgbClr val="028090"/>
           </a:solidFill>
           <a:ln/>
           <a:effectLst>
@@ -5349,54 +5386,73 @@
       </p:sp>
       <p:sp>
         <p:nvSpPr>
-          <p:cNvPr id="10" name="Shape 8"/>
-          <p:cNvSpPr/>
-          <p:nvPr/>
-        </p:nvSpPr>
-        <p:spPr>
-          <a:xfrm>
-            <a:off x="6400800" y="1463040"/>
-            <a:ext cx="5029200" cy="54864"/>
-          </a:xfrm>
-          <a:prstGeom prst="rect">
-            <a:avLst/>
-          </a:prstGeom>
-          <a:solidFill>
-            <a:srgbClr val="02C39A"/>
-          </a:solidFill>
-          <a:ln/>
-        </p:spPr>
-      </p:sp>
-      <p:sp>
-        <p:nvSpPr>
-          <p:cNvPr id="11" name="Text 9"/>
-          <p:cNvSpPr/>
-          <p:nvPr/>
-        </p:nvSpPr>
-        <p:spPr>
-          <a:xfrm>
-            <a:off x="6675120" y="1737360"/>
-            <a:ext cx="2560320" cy="320040"/>
-          </a:xfrm>
-          <a:prstGeom prst="roundRect">
-            <a:avLst>
-              <a:gd name="adj" fmla="val 14286"/>
-            </a:avLst>
-          </a:prstGeom>
-          <a:solidFill>
-            <a:srgbClr val="028090"/>
-          </a:solidFill>
-          <a:ln/>
-        </p:spPr>
-        <p:txBody>
-          <a:bodyPr wrap="square" rtlCol="0" anchor="ctr"/>
-          <a:lstStyle/>
-          <a:p>
-            <a:pPr algn="ctr" indent="0" marL="0">
-              <a:buNone/>
-            </a:pPr>
-            <a:r>
-              <a:rPr lang="en-US" sz="1000" b="1" dirty="0">
+          <p:cNvPr id="9" name="Text 7"/>
+          <p:cNvSpPr/>
+          <p:nvPr/>
+        </p:nvSpPr>
+        <p:spPr>
+          <a:xfrm>
+            <a:off x="6675120" y="2423160"/>
+            <a:ext cx="4480560" cy="411480"/>
+          </a:xfrm>
+          <a:prstGeom prst="rect">
+            <a:avLst/>
+          </a:prstGeom>
+          <a:noFill/>
+          <a:ln/>
+        </p:spPr>
+        <p:txBody>
+          <a:bodyPr wrap="square" rtlCol="0" anchor="ctr"/>
+          <a:lstStyle/>
+          <a:p>
+            <a:pPr indent="0" marL="0">
+              <a:buNone/>
+            </a:pPr>
+            <a:r>
+              <a:rPr lang="en-US" sz="1800" b="1" dirty="0">
+                <a:solidFill>
+                  <a:srgbClr val="FFFFFF"/>
+                </a:solidFill>
+                <a:latin typeface="Trebuchet MS" pitchFamily="34" charset="0"/>
+                <a:ea typeface="Trebuchet MS" pitchFamily="34" charset="-122"/>
+                <a:cs typeface="Trebuchet MS" pitchFamily="34" charset="-120"/>
+              </a:rPr>
+              <a:t>🤝  Acompañamiento</a:t>
+            </a:r>
+            <a:endParaRPr lang="en-US" sz="1800" dirty="0"/>
+          </a:p>
+        </p:txBody>
+      </p:sp>
+      <p:sp>
+        <p:nvSpPr>
+          <p:cNvPr id="10" name="Text 8"/>
+          <p:cNvSpPr/>
+          <p:nvPr/>
+        </p:nvSpPr>
+        <p:spPr>
+          <a:xfrm>
+            <a:off x="6675120" y="2971800"/>
+            <a:ext cx="4480560" cy="3017520"/>
+          </a:xfrm>
+          <a:prstGeom prst="rect">
+            <a:avLst/>
+          </a:prstGeom>
+          <a:noFill/>
+          <a:ln/>
+        </p:spPr>
+        <p:txBody>
+          <a:bodyPr wrap="square" rtlCol="0" anchor="ctr"/>
+          <a:lstStyle/>
+          <a:p>
+            <a:pPr marL="342900" indent="-342900">
+              <a:lnSpc>
+                <a:spcPct val="145000"/>
+              </a:lnSpc>
+              <a:buSzPct val="100000"/>
+              <a:buChar char="✓"/>
+            </a:pPr>
+            <a:r>
+              <a:rPr lang="en-US" sz="1150" dirty="0">
                 <a:solidFill>
                   <a:srgbClr val="FFFFFF"/>
                 </a:solidFill>
@@ -5404,209 +5460,127 @@
                 <a:ea typeface="Calibri" pitchFamily="34" charset="-122"/>
                 <a:cs typeface="Calibri" pitchFamily="34" charset="-120"/>
               </a:rPr>
-              <a:t>CONSULTORÍA + PLATAFORMA</a:t>
-            </a:r>
-            <a:endParaRPr lang="en-US" sz="1000" dirty="0"/>
-          </a:p>
-        </p:txBody>
-      </p:sp>
-      <p:sp>
-        <p:nvSpPr>
-          <p:cNvPr id="12" name="Text 10"/>
-          <p:cNvSpPr/>
-          <p:nvPr/>
-        </p:nvSpPr>
-        <p:spPr>
-          <a:xfrm>
-            <a:off x="6675120" y="2240280"/>
-            <a:ext cx="4480560" cy="365760"/>
-          </a:xfrm>
-          <a:prstGeom prst="rect">
-            <a:avLst/>
-          </a:prstGeom>
-          <a:noFill/>
-          <a:ln/>
-        </p:spPr>
-        <p:txBody>
-          <a:bodyPr wrap="square" rtlCol="0" anchor="ctr"/>
-          <a:lstStyle/>
-          <a:p>
-            <a:pPr indent="0" marL="0">
-              <a:buNone/>
-            </a:pPr>
-            <a:r>
-              <a:rPr lang="en-US" sz="1600" b="1" dirty="0">
-                <a:solidFill>
-                  <a:srgbClr val="1A1A2E"/>
-                </a:solidFill>
-                <a:latin typeface="Trebuchet MS" pitchFamily="34" charset="0"/>
-                <a:ea typeface="Trebuchet MS" pitchFamily="34" charset="-122"/>
-                <a:cs typeface="Trebuchet MS" pitchFamily="34" charset="-120"/>
-              </a:rPr>
-              <a:t>Diagnóstico con interpretación estratégica</a:t>
-            </a:r>
-            <a:endParaRPr lang="en-US" sz="1600" dirty="0"/>
-          </a:p>
-        </p:txBody>
-      </p:sp>
-      <p:sp>
-        <p:nvSpPr>
-          <p:cNvPr id="13" name="Text 11"/>
-          <p:cNvSpPr/>
-          <p:nvPr/>
-        </p:nvSpPr>
-        <p:spPr>
-          <a:xfrm>
-            <a:off x="6675120" y="2651760"/>
-            <a:ext cx="4480560" cy="731520"/>
-          </a:xfrm>
-          <a:prstGeom prst="rect">
-            <a:avLst/>
-          </a:prstGeom>
-          <a:noFill/>
-          <a:ln/>
-        </p:spPr>
-        <p:txBody>
-          <a:bodyPr wrap="square" rtlCol="0" anchor="ctr"/>
-          <a:lstStyle/>
-          <a:p>
-            <a:pPr indent="0" marL="0">
+              <a:t>Diseño de campaña adaptado a tu contexto organizacional</a:t>
+            </a:r>
+            <a:endParaRPr lang="en-US" sz="1150" dirty="0"/>
+          </a:p>
+          <a:p>
+            <a:pPr marL="342900" indent="-342900">
               <a:lnSpc>
-                <a:spcPct val="130000"/>
+                <a:spcPct val="145000"/>
               </a:lnSpc>
-              <a:buNone/>
-            </a:pPr>
-            <a:r>
-              <a:rPr lang="en-US" sz="1200" dirty="0">
-                <a:solidFill>
-                  <a:srgbClr val="4A5568"/>
+              <a:buSzPct val="100000"/>
+              <a:buChar char="✓"/>
+            </a:pPr>
+            <a:r>
+              <a:rPr lang="en-US" sz="1150" dirty="0">
+                <a:solidFill>
+                  <a:srgbClr val="FFFFFF"/>
                 </a:solidFill>
                 <a:latin typeface="Calibri" pitchFamily="34" charset="0"/>
                 <a:ea typeface="Calibri" pitchFamily="34" charset="-122"/>
                 <a:cs typeface="Calibri" pitchFamily="34" charset="-120"/>
               </a:rPr>
-              <a:t>Plataforma más sesiones de análisis, presentación ejecutiva y plan de acción. Para organizaciones que quieren convertir los datos en decisiones de forma inmediata.</a:t>
-            </a:r>
-            <a:endParaRPr lang="en-US" sz="1200" dirty="0"/>
-          </a:p>
-        </p:txBody>
-      </p:sp>
-      <p:sp>
-        <p:nvSpPr>
-          <p:cNvPr id="14" name="Text 12"/>
-          <p:cNvSpPr/>
-          <p:nvPr/>
-        </p:nvSpPr>
-        <p:spPr>
-          <a:xfrm>
-            <a:off x="6675120" y="3566160"/>
-            <a:ext cx="4480560" cy="1828800"/>
-          </a:xfrm>
-          <a:prstGeom prst="rect">
-            <a:avLst/>
-          </a:prstGeom>
-          <a:noFill/>
-          <a:ln/>
-        </p:spPr>
-        <p:txBody>
-          <a:bodyPr wrap="square" rtlCol="0" anchor="ctr"/>
-          <a:lstStyle/>
+              <a:t>Sesión de análisis de resultados con tu equipo</a:t>
+            </a:r>
+            <a:endParaRPr lang="en-US" sz="1150" dirty="0"/>
+          </a:p>
           <a:p>
             <a:pPr marL="342900" indent="-342900">
               <a:lnSpc>
-                <a:spcPct val="150000"/>
+                <a:spcPct val="145000"/>
               </a:lnSpc>
               <a:buSzPct val="100000"/>
               <a:buChar char="✓"/>
             </a:pPr>
             <a:r>
-              <a:rPr lang="en-US" sz="1200" dirty="0">
-                <a:solidFill>
-                  <a:srgbClr val="1A1A2E"/>
+              <a:rPr lang="en-US" sz="1150" dirty="0">
+                <a:solidFill>
+                  <a:srgbClr val="FFFFFF"/>
                 </a:solidFill>
                 <a:latin typeface="Calibri" pitchFamily="34" charset="0"/>
                 <a:ea typeface="Calibri" pitchFamily="34" charset="-122"/>
                 <a:cs typeface="Calibri" pitchFamily="34" charset="-120"/>
               </a:rPr>
-              <a:t>Todo lo de Plataforma</a:t>
-            </a:r>
-            <a:endParaRPr lang="en-US" sz="1200" dirty="0"/>
+              <a:t>Interpretación estratégica: qué significan los datos</a:t>
+            </a:r>
+            <a:endParaRPr lang="en-US" sz="1150" dirty="0"/>
           </a:p>
           <a:p>
             <a:pPr marL="342900" indent="-342900">
               <a:lnSpc>
-                <a:spcPct val="150000"/>
+                <a:spcPct val="145000"/>
               </a:lnSpc>
               <a:buSzPct val="100000"/>
               <a:buChar char="✓"/>
             </a:pPr>
             <a:r>
-              <a:rPr lang="en-US" sz="1200" dirty="0">
-                <a:solidFill>
-                  <a:srgbClr val="1A1A2E"/>
+              <a:rPr lang="en-US" sz="1150" dirty="0">
+                <a:solidFill>
+                  <a:srgbClr val="FFFFFF"/>
                 </a:solidFill>
                 <a:latin typeface="Calibri" pitchFamily="34" charset="0"/>
                 <a:ea typeface="Calibri" pitchFamily="34" charset="-122"/>
                 <a:cs typeface="Calibri" pitchFamily="34" charset="-120"/>
               </a:rPr>
-              <a:t>Sesión de análisis de resultados</a:t>
-            </a:r>
-            <a:endParaRPr lang="en-US" sz="1200" dirty="0"/>
+              <a:t>Presentación ejecutiva para el comité directivo</a:t>
+            </a:r>
+            <a:endParaRPr lang="en-US" sz="1150" dirty="0"/>
           </a:p>
           <a:p>
             <a:pPr marL="342900" indent="-342900">
               <a:lnSpc>
-                <a:spcPct val="150000"/>
+                <a:spcPct val="145000"/>
               </a:lnSpc>
               <a:buSzPct val="100000"/>
               <a:buChar char="✓"/>
             </a:pPr>
             <a:r>
-              <a:rPr lang="en-US" sz="1200" dirty="0">
-                <a:solidFill>
-                  <a:srgbClr val="1A1A2E"/>
+              <a:rPr lang="en-US" sz="1150" dirty="0">
+                <a:solidFill>
+                  <a:srgbClr val="FFFFFF"/>
                 </a:solidFill>
                 <a:latin typeface="Calibri" pitchFamily="34" charset="0"/>
                 <a:ea typeface="Calibri" pitchFamily="34" charset="-122"/>
                 <a:cs typeface="Calibri" pitchFamily="34" charset="-120"/>
               </a:rPr>
-              <a:t>Presentación al comité directivo</a:t>
-            </a:r>
-            <a:endParaRPr lang="en-US" sz="1200" dirty="0"/>
+              <a:t>Identificación de quick wins y focos de intervención</a:t>
+            </a:r>
+            <a:endParaRPr lang="en-US" sz="1150" dirty="0"/>
           </a:p>
           <a:p>
             <a:pPr marL="342900" indent="-342900">
               <a:lnSpc>
-                <a:spcPct val="150000"/>
+                <a:spcPct val="145000"/>
               </a:lnSpc>
               <a:buSzPct val="100000"/>
               <a:buChar char="✓"/>
             </a:pPr>
             <a:r>
-              <a:rPr lang="en-US" sz="1200" dirty="0">
-                <a:solidFill>
-                  <a:srgbClr val="1A1A2E"/>
+              <a:rPr lang="en-US" sz="1150" dirty="0">
+                <a:solidFill>
+                  <a:srgbClr val="FFFFFF"/>
                 </a:solidFill>
                 <a:latin typeface="Calibri" pitchFamily="34" charset="0"/>
                 <a:ea typeface="Calibri" pitchFamily="34" charset="-122"/>
                 <a:cs typeface="Calibri" pitchFamily="34" charset="-120"/>
               </a:rPr>
-              <a:t>Identificación de quick wins y plan de 90 días</a:t>
-            </a:r>
-            <a:endParaRPr lang="en-US" sz="1200" dirty="0"/>
-          </a:p>
-        </p:txBody>
-      </p:sp>
-      <p:sp>
-        <p:nvSpPr>
-          <p:cNvPr id="15" name="Text 13"/>
-          <p:cNvSpPr/>
-          <p:nvPr/>
-        </p:nvSpPr>
-        <p:spPr>
-          <a:xfrm>
-            <a:off x="731520" y="6126480"/>
-            <a:ext cx="10515600" cy="365760"/>
+              <a:t>Plan de acción con horizonte de 90 días</a:t>
+            </a:r>
+            <a:endParaRPr lang="en-US" sz="1150" dirty="0"/>
+          </a:p>
+        </p:txBody>
+      </p:sp>
+      <p:sp>
+        <p:nvSpPr>
+          <p:cNvPr id="11" name="Text 9"/>
+          <p:cNvSpPr/>
+          <p:nvPr/>
+        </p:nvSpPr>
+        <p:spPr>
+          <a:xfrm>
+            <a:off x="731520" y="6400800"/>
+            <a:ext cx="10515600" cy="320040"/>
           </a:xfrm>
           <a:prstGeom prst="rect">
             <a:avLst/>
@@ -5630,7 +5604,7 @@
                 <a:ea typeface="Calibri" pitchFamily="34" charset="-122"/>
                 <a:cs typeface="Calibri" pitchFamily="34" charset="-120"/>
               </a:rPr>
-              <a:t>[NOMBRE DE TU EMPRESA] puede orientarte sobre la modalidad más adecuada para el tamaño y madurez de tu organización.</a:t>
+              <a:t>El valor no está en los datos — está en lo que haces con ellos. Por eso cada diagnóstico incluye acompañamiento.</a:t>
             </a:r>
             <a:endParaRPr lang="en-US" sz="1100" dirty="0"/>
           </a:p>

</xml_diff>